<commit_message>
Update BOG presentation: remove branding tagline, simplify journey slide, drop Q&A/mission split, swap in Cebuano topic screenshot, replace problem video with problem statement
Co-Authored-By: Claude Sonnet 5 <noreply@anthropic.com>
</commit_message>
<xml_diff>
--- a/documents/BOG_PREENTATION/1presentation-aug-30/iCFD-Board-of-Governors-Presentation.pptx
+++ b/documents/BOG_PREENTATION/1presentation-aug-30/iCFD-Board-of-Governors-Presentation.pptx
@@ -4536,7 +4536,7 @@
                 <a:ea typeface="Arial" pitchFamily="34" charset="-122"/>
                 <a:cs typeface="Arial" pitchFamily="34" charset="-120"/>
               </a:rPr>
-              <a:t>A Real Topic Page</a:t>
+              <a:t>A Real Topic Page — in Cebuano</a:t>
             </a:r>
             <a:endParaRPr lang="en-US" sz="2600" dirty="0"/>
           </a:p>
@@ -16400,7 +16400,7 @@
     <p:bg>
       <p:bgPr>
         <a:solidFill>
-          <a:srgbClr val="10182F"/>
+          <a:srgbClr val="FFFFFF"/>
         </a:solidFill>
       </p:bgPr>
     </p:bg>
@@ -16426,34 +16426,34 @@
         </p:nvSpPr>
         <p:spPr>
           <a:xfrm>
-            <a:off x="914400" y="2560320"/>
-            <a:ext cx="10360152" cy="822960"/>
-          </a:xfrm>
-          <a:prstGeom prst="rect">
-            <a:avLst/>
-          </a:prstGeom>
-          <a:noFill/>
-          <a:ln/>
-        </p:spPr>
-        <p:txBody>
-          <a:bodyPr wrap="square" rtlCol="0" anchor="ctr"/>
-          <a:lstStyle/>
-          <a:p>
-            <a:pPr algn="ctr" indent="0" marL="0">
-              <a:buNone/>
-            </a:pPr>
-            <a:r>
-              <a:rPr lang="en-US" sz="3400" b="1" dirty="0">
-                <a:solidFill>
-                  <a:srgbClr val="FFFFFF"/>
-                </a:solidFill>
-                <a:latin typeface="Arial" pitchFamily="34" charset="0"/>
-                <a:ea typeface="Arial" pitchFamily="34" charset="-122"/>
-                <a:cs typeface="Arial" pitchFamily="34" charset="-120"/>
-              </a:rPr>
-              <a:t>The Problem We Are Trying to Solve</a:t>
-            </a:r>
-            <a:endParaRPr lang="en-US" sz="3400" dirty="0"/>
+            <a:off x="548640" y="411480"/>
+            <a:ext cx="9144000" cy="320040"/>
+          </a:xfrm>
+          <a:prstGeom prst="rect">
+            <a:avLst/>
+          </a:prstGeom>
+          <a:noFill/>
+          <a:ln/>
+        </p:spPr>
+        <p:txBody>
+          <a:bodyPr wrap="square" rtlCol="0" anchor="ctr"/>
+          <a:lstStyle/>
+          <a:p>
+            <a:pPr indent="0" marL="0">
+              <a:buNone/>
+            </a:pPr>
+            <a:r>
+              <a:rPr lang="en-US" sz="1200" b="1" spc="200" kern="0" dirty="0">
+                <a:solidFill>
+                  <a:srgbClr val="1557A6"/>
+                </a:solidFill>
+                <a:latin typeface="Arial" pitchFamily="34" charset="0"/>
+                <a:ea typeface="Arial" pitchFamily="34" charset="-122"/>
+                <a:cs typeface="Arial" pitchFamily="34" charset="-120"/>
+              </a:rPr>
+              <a:t>THE PROBLEM WE ARE TRYING TO SOLVE</a:t>
+            </a:r>
+            <a:endParaRPr lang="en-US" sz="1200" dirty="0"/>
           </a:p>
         </p:txBody>
       </p:sp>
@@ -16465,40 +16465,187 @@
         </p:nvSpPr>
         <p:spPr>
           <a:xfrm>
-            <a:off x="1984248" y="3566160"/>
-            <a:ext cx="8229600" cy="914400"/>
-          </a:xfrm>
-          <a:prstGeom prst="rect">
-            <a:avLst/>
-          </a:prstGeom>
-          <a:noFill/>
-          <a:ln/>
-        </p:spPr>
-        <p:txBody>
-          <a:bodyPr wrap="square" rtlCol="0" anchor="ctr"/>
-          <a:lstStyle/>
-          <a:p>
-            <a:pPr algn="ctr" indent="0" marL="0">
-              <a:buNone/>
-            </a:pPr>
-            <a:r>
-              <a:rPr lang="en-US" sz="1300" i="1" dirty="0">
-                <a:solidFill>
-                  <a:srgbClr val="E7D98A"/>
-                </a:solidFill>
-                <a:latin typeface="Arial" pitchFamily="34" charset="0"/>
-                <a:ea typeface="Arial" pitchFamily="34" charset="-122"/>
-                <a:cs typeface="Arial" pitchFamily="34" charset="-120"/>
-              </a:rPr>
-              <a:t>No video file exists in the repository as of this build. If a problem video has been produced outside the codebase, insert it here full-screen; otherwise narrate this transition live.</a:t>
-            </a:r>
-            <a:endParaRPr lang="en-US" sz="1300" dirty="0"/>
-          </a:p>
-        </p:txBody>
-      </p:sp>
-      <p:sp>
-        <p:nvSpPr>
-          <p:cNvPr id="4" name="Text 2"/>
+            <a:off x="548640" y="713232"/>
+            <a:ext cx="11155680" cy="914400"/>
+          </a:xfrm>
+          <a:prstGeom prst="rect">
+            <a:avLst/>
+          </a:prstGeom>
+          <a:noFill/>
+          <a:ln/>
+        </p:spPr>
+        <p:txBody>
+          <a:bodyPr wrap="square" rtlCol="0" anchor="ctr"/>
+          <a:lstStyle/>
+          <a:p>
+            <a:pPr indent="0" marL="0">
+              <a:buNone/>
+            </a:pPr>
+            <a:r>
+              <a:rPr lang="en-US" sz="2600" b="1" dirty="0">
+                <a:solidFill>
+                  <a:srgbClr val="10182F"/>
+                </a:solidFill>
+                <a:latin typeface="Arial" pitchFamily="34" charset="0"/>
+                <a:ea typeface="Arial" pitchFamily="34" charset="-122"/>
+                <a:cs typeface="Arial" pitchFamily="34" charset="-120"/>
+              </a:rPr>
+              <a:t>Five Problems iCFD Was Built to Address</a:t>
+            </a:r>
+            <a:endParaRPr lang="en-US" sz="2600" dirty="0"/>
+          </a:p>
+        </p:txBody>
+      </p:sp>
+      <p:sp>
+        <p:nvSpPr>
+          <p:cNvPr id="4" name="Shape 2"/>
+          <p:cNvSpPr/>
+          <p:nvPr/>
+        </p:nvSpPr>
+        <p:spPr>
+          <a:xfrm>
+            <a:off x="548640" y="1481328"/>
+            <a:ext cx="502920" cy="54864"/>
+          </a:xfrm>
+          <a:prstGeom prst="rect">
+            <a:avLst/>
+          </a:prstGeom>
+          <a:solidFill>
+            <a:srgbClr val="F2D21F"/>
+          </a:solidFill>
+          <a:ln/>
+        </p:spPr>
+      </p:sp>
+      <p:sp>
+        <p:nvSpPr>
+          <p:cNvPr id="5" name="Text 3"/>
+          <p:cNvSpPr/>
+          <p:nvPr/>
+        </p:nvSpPr>
+        <p:spPr>
+          <a:xfrm>
+            <a:off x="640080" y="1828800"/>
+            <a:ext cx="10881360" cy="4389120"/>
+          </a:xfrm>
+          <a:prstGeom prst="rect">
+            <a:avLst/>
+          </a:prstGeom>
+          <a:noFill/>
+          <a:ln/>
+        </p:spPr>
+        <p:txBody>
+          <a:bodyPr wrap="square" rtlCol="0" anchor="ctr"/>
+          <a:lstStyle/>
+          <a:p>
+            <a:pPr marL="342900" indent="-342900">
+              <a:spcAft>
+                <a:spcPts val="800"/>
+              </a:spcAft>
+              <a:buSzPct val="100000"/>
+              <a:buChar char="•"/>
+            </a:pPr>
+            <a:r>
+              <a:rPr lang="en-US" sz="1500" dirty="0">
+                <a:solidFill>
+                  <a:srgbClr val="1A1F2B"/>
+                </a:solidFill>
+                <a:latin typeface="Arial" pitchFamily="34" charset="0"/>
+                <a:ea typeface="Arial" pitchFamily="34" charset="-122"/>
+                <a:cs typeface="Arial" pitchFamily="34" charset="-120"/>
+              </a:rPr>
+              <a:t>Catholic teaching material is scattered across many disconnected sources — Bible, Catechism, Church documents, apologetics, theology, Church Fathers.</a:t>
+            </a:r>
+            <a:endParaRPr lang="en-US" sz="1500" dirty="0"/>
+          </a:p>
+          <a:p>
+            <a:pPr marL="342900" indent="-342900">
+              <a:spcAft>
+                <a:spcPts val="800"/>
+              </a:spcAft>
+              <a:buSzPct val="100000"/>
+              <a:buChar char="•"/>
+            </a:pPr>
+            <a:r>
+              <a:rPr lang="en-US" sz="1500" dirty="0">
+                <a:solidFill>
+                  <a:srgbClr val="1A1F2B"/>
+                </a:solidFill>
+                <a:latin typeface="Arial" pitchFamily="34" charset="0"/>
+                <a:ea typeface="Arial" pitchFamily="34" charset="-122"/>
+                <a:cs typeface="Arial" pitchFamily="34" charset="-120"/>
+              </a:rPr>
+              <a:t>Members don't know where to start or what to study next — there is no guided path through the material.</a:t>
+            </a:r>
+            <a:endParaRPr lang="en-US" sz="1500" dirty="0"/>
+          </a:p>
+          <a:p>
+            <a:pPr marL="342900" indent="-342900">
+              <a:spcAft>
+                <a:spcPts val="800"/>
+              </a:spcAft>
+              <a:buSzPct val="100000"/>
+              <a:buChar char="•"/>
+            </a:pPr>
+            <a:r>
+              <a:rPr lang="en-US" sz="1500" dirty="0">
+                <a:solidFill>
+                  <a:srgbClr val="1A1F2B"/>
+                </a:solidFill>
+                <a:latin typeface="Arial" pitchFamily="34" charset="0"/>
+                <a:ea typeface="Arial" pitchFamily="34" charset="-122"/>
+                <a:cs typeface="Arial" pitchFamily="34" charset="-120"/>
+              </a:rPr>
+              <a:t>There is no simple way to evaluate how well a member is actually learning — formation has no measurable feedback loop.</a:t>
+            </a:r>
+            <a:endParaRPr lang="en-US" sz="1500" dirty="0"/>
+          </a:p>
+          <a:p>
+            <a:pPr marL="342900" indent="-342900">
+              <a:spcAft>
+                <a:spcPts val="800"/>
+              </a:spcAft>
+              <a:buSzPct val="100000"/>
+              <a:buChar char="•"/>
+            </a:pPr>
+            <a:r>
+              <a:rPr lang="en-US" sz="1500" dirty="0">
+                <a:solidFill>
+                  <a:srgbClr val="1A1F2B"/>
+                </a:solidFill>
+                <a:latin typeface="Arial" pitchFamily="34" charset="0"/>
+                <a:ea typeface="Arial" pitchFamily="34" charset="-122"/>
+                <a:cs typeface="Arial" pitchFamily="34" charset="-120"/>
+              </a:rPr>
+              <a:t>Educators and catechists lack a focused tool to guide members with good content — most teaching still depends on scattered personal effort.</a:t>
+            </a:r>
+            <a:endParaRPr lang="en-US" sz="1500" dirty="0"/>
+          </a:p>
+          <a:p>
+            <a:pPr marL="342900" indent="-342900">
+              <a:spcAft>
+                <a:spcPts val="800"/>
+              </a:spcAft>
+              <a:buSzPct val="100000"/>
+              <a:buChar char="•"/>
+            </a:pPr>
+            <a:r>
+              <a:rPr lang="en-US" sz="1500" dirty="0">
+                <a:solidFill>
+                  <a:srgbClr val="1A1F2B"/>
+                </a:solidFill>
+                <a:latin typeface="Arial" pitchFamily="34" charset="0"/>
+                <a:ea typeface="Arial" pitchFamily="34" charset="-122"/>
+                <a:cs typeface="Arial" pitchFamily="34" charset="-120"/>
+              </a:rPr>
+              <a:t>Existing material isn't always available offline or in the member's own language (Cebuano, Tagalog).</a:t>
+            </a:r>
+            <a:endParaRPr lang="en-US" sz="1500" dirty="0"/>
+          </a:p>
+        </p:txBody>
+      </p:sp>
+      <p:sp>
+        <p:nvSpPr>
+          <p:cNvPr id="6" name="Text 4"/>
           <p:cNvSpPr/>
           <p:nvPr/>
         </p:nvSpPr>
@@ -16523,7 +16670,7 @@
             <a:r>
               <a:rPr lang="en-US" sz="1000" dirty="0">
                 <a:solidFill>
-                  <a:srgbClr val="C9D3EA"/>
+                  <a:srgbClr val="5B6472"/>
                 </a:solidFill>
                 <a:latin typeface="Arial" pitchFamily="34" charset="0"/>
                 <a:ea typeface="Arial" pitchFamily="34" charset="-122"/>
@@ -16537,7 +16684,7 @@
       </p:sp>
       <p:sp>
         <p:nvSpPr>
-          <p:cNvPr id="5" name="Text 3"/>
+          <p:cNvPr id="7" name="Text 5"/>
           <p:cNvSpPr/>
           <p:nvPr/>
         </p:nvSpPr>
@@ -16562,7 +16709,7 @@
             <a:r>
               <a:rPr lang="en-US" sz="1000" dirty="0">
                 <a:solidFill>
-                  <a:srgbClr val="C9D3EA"/>
+                  <a:srgbClr val="5B6472"/>
                 </a:solidFill>
                 <a:latin typeface="Arial" pitchFamily="34" charset="0"/>
                 <a:ea typeface="Arial" pitchFamily="34" charset="-122"/>

</xml_diff>

<commit_message>
iteration 1.0.2 — develop merge (#11)
* Update BOG presentation: remove branding tagline, simplify journey slide, drop Q&A/mission split, swap in Cebuano topic screenshot, replace problem video with problem statement

Co-Authored-By: Claude Sonnet 5 <noreply@anthropic.com>

* fix images on recommednatiosn

* Add full-bleed hero image to topic pages with overlapping content card

Content card overlaps the image's lower edge with a theme-aware shadow
and a background-token scrim, so text stays legible regardless of the
photo's own contrast in either light or dark mode. Extracts the
category gradient/photo lookup (previously duplicated only in
DailyCarousel) into a shared lib/content/categoryVisuals module.

Co-Authored-By: Claude Sonnet 5 <noreply@anthropic.com>
Claude-Session: https://claude.ai/code/session_01GhsxTewx2ufCiC4QVnyK4k

---------

Co-authored-by: Claude Sonnet 5 <noreply@anthropic.com>
</commit_message>
<xml_diff>
--- a/documents/BOG_PREENTATION/1presentation-aug-30/iCFD-Board-of-Governors-Presentation.pptx
+++ b/documents/BOG_PREENTATION/1presentation-aug-30/iCFD-Board-of-Governors-Presentation.pptx
@@ -4536,7 +4536,7 @@
                 <a:ea typeface="Arial" pitchFamily="34" charset="-122"/>
                 <a:cs typeface="Arial" pitchFamily="34" charset="-120"/>
               </a:rPr>
-              <a:t>A Real Topic Page</a:t>
+              <a:t>A Real Topic Page — in Cebuano</a:t>
             </a:r>
             <a:endParaRPr lang="en-US" sz="2600" dirty="0"/>
           </a:p>
@@ -16400,7 +16400,7 @@
     <p:bg>
       <p:bgPr>
         <a:solidFill>
-          <a:srgbClr val="10182F"/>
+          <a:srgbClr val="FFFFFF"/>
         </a:solidFill>
       </p:bgPr>
     </p:bg>
@@ -16426,34 +16426,34 @@
         </p:nvSpPr>
         <p:spPr>
           <a:xfrm>
-            <a:off x="914400" y="2560320"/>
-            <a:ext cx="10360152" cy="822960"/>
-          </a:xfrm>
-          <a:prstGeom prst="rect">
-            <a:avLst/>
-          </a:prstGeom>
-          <a:noFill/>
-          <a:ln/>
-        </p:spPr>
-        <p:txBody>
-          <a:bodyPr wrap="square" rtlCol="0" anchor="ctr"/>
-          <a:lstStyle/>
-          <a:p>
-            <a:pPr algn="ctr" indent="0" marL="0">
-              <a:buNone/>
-            </a:pPr>
-            <a:r>
-              <a:rPr lang="en-US" sz="3400" b="1" dirty="0">
-                <a:solidFill>
-                  <a:srgbClr val="FFFFFF"/>
-                </a:solidFill>
-                <a:latin typeface="Arial" pitchFamily="34" charset="0"/>
-                <a:ea typeface="Arial" pitchFamily="34" charset="-122"/>
-                <a:cs typeface="Arial" pitchFamily="34" charset="-120"/>
-              </a:rPr>
-              <a:t>The Problem We Are Trying to Solve</a:t>
-            </a:r>
-            <a:endParaRPr lang="en-US" sz="3400" dirty="0"/>
+            <a:off x="548640" y="411480"/>
+            <a:ext cx="9144000" cy="320040"/>
+          </a:xfrm>
+          <a:prstGeom prst="rect">
+            <a:avLst/>
+          </a:prstGeom>
+          <a:noFill/>
+          <a:ln/>
+        </p:spPr>
+        <p:txBody>
+          <a:bodyPr wrap="square" rtlCol="0" anchor="ctr"/>
+          <a:lstStyle/>
+          <a:p>
+            <a:pPr indent="0" marL="0">
+              <a:buNone/>
+            </a:pPr>
+            <a:r>
+              <a:rPr lang="en-US" sz="1200" b="1" spc="200" kern="0" dirty="0">
+                <a:solidFill>
+                  <a:srgbClr val="1557A6"/>
+                </a:solidFill>
+                <a:latin typeface="Arial" pitchFamily="34" charset="0"/>
+                <a:ea typeface="Arial" pitchFamily="34" charset="-122"/>
+                <a:cs typeface="Arial" pitchFamily="34" charset="-120"/>
+              </a:rPr>
+              <a:t>THE PROBLEM WE ARE TRYING TO SOLVE</a:t>
+            </a:r>
+            <a:endParaRPr lang="en-US" sz="1200" dirty="0"/>
           </a:p>
         </p:txBody>
       </p:sp>
@@ -16465,40 +16465,187 @@
         </p:nvSpPr>
         <p:spPr>
           <a:xfrm>
-            <a:off x="1984248" y="3566160"/>
-            <a:ext cx="8229600" cy="914400"/>
-          </a:xfrm>
-          <a:prstGeom prst="rect">
-            <a:avLst/>
-          </a:prstGeom>
-          <a:noFill/>
-          <a:ln/>
-        </p:spPr>
-        <p:txBody>
-          <a:bodyPr wrap="square" rtlCol="0" anchor="ctr"/>
-          <a:lstStyle/>
-          <a:p>
-            <a:pPr algn="ctr" indent="0" marL="0">
-              <a:buNone/>
-            </a:pPr>
-            <a:r>
-              <a:rPr lang="en-US" sz="1300" i="1" dirty="0">
-                <a:solidFill>
-                  <a:srgbClr val="E7D98A"/>
-                </a:solidFill>
-                <a:latin typeface="Arial" pitchFamily="34" charset="0"/>
-                <a:ea typeface="Arial" pitchFamily="34" charset="-122"/>
-                <a:cs typeface="Arial" pitchFamily="34" charset="-120"/>
-              </a:rPr>
-              <a:t>No video file exists in the repository as of this build. If a problem video has been produced outside the codebase, insert it here full-screen; otherwise narrate this transition live.</a:t>
-            </a:r>
-            <a:endParaRPr lang="en-US" sz="1300" dirty="0"/>
-          </a:p>
-        </p:txBody>
-      </p:sp>
-      <p:sp>
-        <p:nvSpPr>
-          <p:cNvPr id="4" name="Text 2"/>
+            <a:off x="548640" y="713232"/>
+            <a:ext cx="11155680" cy="914400"/>
+          </a:xfrm>
+          <a:prstGeom prst="rect">
+            <a:avLst/>
+          </a:prstGeom>
+          <a:noFill/>
+          <a:ln/>
+        </p:spPr>
+        <p:txBody>
+          <a:bodyPr wrap="square" rtlCol="0" anchor="ctr"/>
+          <a:lstStyle/>
+          <a:p>
+            <a:pPr indent="0" marL="0">
+              <a:buNone/>
+            </a:pPr>
+            <a:r>
+              <a:rPr lang="en-US" sz="2600" b="1" dirty="0">
+                <a:solidFill>
+                  <a:srgbClr val="10182F"/>
+                </a:solidFill>
+                <a:latin typeface="Arial" pitchFamily="34" charset="0"/>
+                <a:ea typeface="Arial" pitchFamily="34" charset="-122"/>
+                <a:cs typeface="Arial" pitchFamily="34" charset="-120"/>
+              </a:rPr>
+              <a:t>Five Problems iCFD Was Built to Address</a:t>
+            </a:r>
+            <a:endParaRPr lang="en-US" sz="2600" dirty="0"/>
+          </a:p>
+        </p:txBody>
+      </p:sp>
+      <p:sp>
+        <p:nvSpPr>
+          <p:cNvPr id="4" name="Shape 2"/>
+          <p:cNvSpPr/>
+          <p:nvPr/>
+        </p:nvSpPr>
+        <p:spPr>
+          <a:xfrm>
+            <a:off x="548640" y="1481328"/>
+            <a:ext cx="502920" cy="54864"/>
+          </a:xfrm>
+          <a:prstGeom prst="rect">
+            <a:avLst/>
+          </a:prstGeom>
+          <a:solidFill>
+            <a:srgbClr val="F2D21F"/>
+          </a:solidFill>
+          <a:ln/>
+        </p:spPr>
+      </p:sp>
+      <p:sp>
+        <p:nvSpPr>
+          <p:cNvPr id="5" name="Text 3"/>
+          <p:cNvSpPr/>
+          <p:nvPr/>
+        </p:nvSpPr>
+        <p:spPr>
+          <a:xfrm>
+            <a:off x="640080" y="1828800"/>
+            <a:ext cx="10881360" cy="4389120"/>
+          </a:xfrm>
+          <a:prstGeom prst="rect">
+            <a:avLst/>
+          </a:prstGeom>
+          <a:noFill/>
+          <a:ln/>
+        </p:spPr>
+        <p:txBody>
+          <a:bodyPr wrap="square" rtlCol="0" anchor="ctr"/>
+          <a:lstStyle/>
+          <a:p>
+            <a:pPr marL="342900" indent="-342900">
+              <a:spcAft>
+                <a:spcPts val="800"/>
+              </a:spcAft>
+              <a:buSzPct val="100000"/>
+              <a:buChar char="•"/>
+            </a:pPr>
+            <a:r>
+              <a:rPr lang="en-US" sz="1500" dirty="0">
+                <a:solidFill>
+                  <a:srgbClr val="1A1F2B"/>
+                </a:solidFill>
+                <a:latin typeface="Arial" pitchFamily="34" charset="0"/>
+                <a:ea typeface="Arial" pitchFamily="34" charset="-122"/>
+                <a:cs typeface="Arial" pitchFamily="34" charset="-120"/>
+              </a:rPr>
+              <a:t>Catholic teaching material is scattered across many disconnected sources — Bible, Catechism, Church documents, apologetics, theology, Church Fathers.</a:t>
+            </a:r>
+            <a:endParaRPr lang="en-US" sz="1500" dirty="0"/>
+          </a:p>
+          <a:p>
+            <a:pPr marL="342900" indent="-342900">
+              <a:spcAft>
+                <a:spcPts val="800"/>
+              </a:spcAft>
+              <a:buSzPct val="100000"/>
+              <a:buChar char="•"/>
+            </a:pPr>
+            <a:r>
+              <a:rPr lang="en-US" sz="1500" dirty="0">
+                <a:solidFill>
+                  <a:srgbClr val="1A1F2B"/>
+                </a:solidFill>
+                <a:latin typeface="Arial" pitchFamily="34" charset="0"/>
+                <a:ea typeface="Arial" pitchFamily="34" charset="-122"/>
+                <a:cs typeface="Arial" pitchFamily="34" charset="-120"/>
+              </a:rPr>
+              <a:t>Members don't know where to start or what to study next — there is no guided path through the material.</a:t>
+            </a:r>
+            <a:endParaRPr lang="en-US" sz="1500" dirty="0"/>
+          </a:p>
+          <a:p>
+            <a:pPr marL="342900" indent="-342900">
+              <a:spcAft>
+                <a:spcPts val="800"/>
+              </a:spcAft>
+              <a:buSzPct val="100000"/>
+              <a:buChar char="•"/>
+            </a:pPr>
+            <a:r>
+              <a:rPr lang="en-US" sz="1500" dirty="0">
+                <a:solidFill>
+                  <a:srgbClr val="1A1F2B"/>
+                </a:solidFill>
+                <a:latin typeface="Arial" pitchFamily="34" charset="0"/>
+                <a:ea typeface="Arial" pitchFamily="34" charset="-122"/>
+                <a:cs typeface="Arial" pitchFamily="34" charset="-120"/>
+              </a:rPr>
+              <a:t>There is no simple way to evaluate how well a member is actually learning — formation has no measurable feedback loop.</a:t>
+            </a:r>
+            <a:endParaRPr lang="en-US" sz="1500" dirty="0"/>
+          </a:p>
+          <a:p>
+            <a:pPr marL="342900" indent="-342900">
+              <a:spcAft>
+                <a:spcPts val="800"/>
+              </a:spcAft>
+              <a:buSzPct val="100000"/>
+              <a:buChar char="•"/>
+            </a:pPr>
+            <a:r>
+              <a:rPr lang="en-US" sz="1500" dirty="0">
+                <a:solidFill>
+                  <a:srgbClr val="1A1F2B"/>
+                </a:solidFill>
+                <a:latin typeface="Arial" pitchFamily="34" charset="0"/>
+                <a:ea typeface="Arial" pitchFamily="34" charset="-122"/>
+                <a:cs typeface="Arial" pitchFamily="34" charset="-120"/>
+              </a:rPr>
+              <a:t>Educators and catechists lack a focused tool to guide members with good content — most teaching still depends on scattered personal effort.</a:t>
+            </a:r>
+            <a:endParaRPr lang="en-US" sz="1500" dirty="0"/>
+          </a:p>
+          <a:p>
+            <a:pPr marL="342900" indent="-342900">
+              <a:spcAft>
+                <a:spcPts val="800"/>
+              </a:spcAft>
+              <a:buSzPct val="100000"/>
+              <a:buChar char="•"/>
+            </a:pPr>
+            <a:r>
+              <a:rPr lang="en-US" sz="1500" dirty="0">
+                <a:solidFill>
+                  <a:srgbClr val="1A1F2B"/>
+                </a:solidFill>
+                <a:latin typeface="Arial" pitchFamily="34" charset="0"/>
+                <a:ea typeface="Arial" pitchFamily="34" charset="-122"/>
+                <a:cs typeface="Arial" pitchFamily="34" charset="-120"/>
+              </a:rPr>
+              <a:t>Existing material isn't always available offline or in the member's own language (Cebuano, Tagalog).</a:t>
+            </a:r>
+            <a:endParaRPr lang="en-US" sz="1500" dirty="0"/>
+          </a:p>
+        </p:txBody>
+      </p:sp>
+      <p:sp>
+        <p:nvSpPr>
+          <p:cNvPr id="6" name="Text 4"/>
           <p:cNvSpPr/>
           <p:nvPr/>
         </p:nvSpPr>
@@ -16523,7 +16670,7 @@
             <a:r>
               <a:rPr lang="en-US" sz="1000" dirty="0">
                 <a:solidFill>
-                  <a:srgbClr val="C9D3EA"/>
+                  <a:srgbClr val="5B6472"/>
                 </a:solidFill>
                 <a:latin typeface="Arial" pitchFamily="34" charset="0"/>
                 <a:ea typeface="Arial" pitchFamily="34" charset="-122"/>
@@ -16537,7 +16684,7 @@
       </p:sp>
       <p:sp>
         <p:nvSpPr>
-          <p:cNvPr id="5" name="Text 3"/>
+          <p:cNvPr id="7" name="Text 5"/>
           <p:cNvSpPr/>
           <p:nvPr/>
         </p:nvSpPr>
@@ -16562,7 +16709,7 @@
             <a:r>
               <a:rPr lang="en-US" sz="1000" dirty="0">
                 <a:solidFill>
-                  <a:srgbClr val="C9D3EA"/>
+                  <a:srgbClr val="5B6472"/>
                 </a:solidFill>
                 <a:latin typeface="Arial" pitchFamily="34" charset="0"/>
                 <a:ea typeface="Arial" pitchFamily="34" charset="-122"/>

</xml_diff>

<commit_message>
iteration 1.0.2 — develop merge (#11) (#12)
* Update BOG presentation: remove branding tagline, simplify journey slide, drop Q&A/mission split, swap in Cebuano topic screenshot, replace problem video with problem statement



* fix images on recommednatiosn

* Add full-bleed hero image to topic pages with overlapping content card

Content card overlaps the image's lower edge with a theme-aware shadow
and a background-token scrim, so text stays legible regardless of the
photo's own contrast in either light or dark mode. Extracts the
category gradient/photo lookup (previously duplicated only in
DailyCarousel) into a shared lib/content/categoryVisuals module.


Claude-Session: https://claude.ai/code/session_01GhsxTewx2ufCiC4QVnyK4k

---------

Co-authored-by: Claude Sonnet 5 <noreply@anthropic.com>
</commit_message>
<xml_diff>
--- a/documents/BOG_PREENTATION/1presentation-aug-30/iCFD-Board-of-Governors-Presentation.pptx
+++ b/documents/BOG_PREENTATION/1presentation-aug-30/iCFD-Board-of-Governors-Presentation.pptx
@@ -4536,7 +4536,7 @@
                 <a:ea typeface="Arial" pitchFamily="34" charset="-122"/>
                 <a:cs typeface="Arial" pitchFamily="34" charset="-120"/>
               </a:rPr>
-              <a:t>A Real Topic Page</a:t>
+              <a:t>A Real Topic Page — in Cebuano</a:t>
             </a:r>
             <a:endParaRPr lang="en-US" sz="2600" dirty="0"/>
           </a:p>
@@ -16400,7 +16400,7 @@
     <p:bg>
       <p:bgPr>
         <a:solidFill>
-          <a:srgbClr val="10182F"/>
+          <a:srgbClr val="FFFFFF"/>
         </a:solidFill>
       </p:bgPr>
     </p:bg>
@@ -16426,34 +16426,34 @@
         </p:nvSpPr>
         <p:spPr>
           <a:xfrm>
-            <a:off x="914400" y="2560320"/>
-            <a:ext cx="10360152" cy="822960"/>
-          </a:xfrm>
-          <a:prstGeom prst="rect">
-            <a:avLst/>
-          </a:prstGeom>
-          <a:noFill/>
-          <a:ln/>
-        </p:spPr>
-        <p:txBody>
-          <a:bodyPr wrap="square" rtlCol="0" anchor="ctr"/>
-          <a:lstStyle/>
-          <a:p>
-            <a:pPr algn="ctr" indent="0" marL="0">
-              <a:buNone/>
-            </a:pPr>
-            <a:r>
-              <a:rPr lang="en-US" sz="3400" b="1" dirty="0">
-                <a:solidFill>
-                  <a:srgbClr val="FFFFFF"/>
-                </a:solidFill>
-                <a:latin typeface="Arial" pitchFamily="34" charset="0"/>
-                <a:ea typeface="Arial" pitchFamily="34" charset="-122"/>
-                <a:cs typeface="Arial" pitchFamily="34" charset="-120"/>
-              </a:rPr>
-              <a:t>The Problem We Are Trying to Solve</a:t>
-            </a:r>
-            <a:endParaRPr lang="en-US" sz="3400" dirty="0"/>
+            <a:off x="548640" y="411480"/>
+            <a:ext cx="9144000" cy="320040"/>
+          </a:xfrm>
+          <a:prstGeom prst="rect">
+            <a:avLst/>
+          </a:prstGeom>
+          <a:noFill/>
+          <a:ln/>
+        </p:spPr>
+        <p:txBody>
+          <a:bodyPr wrap="square" rtlCol="0" anchor="ctr"/>
+          <a:lstStyle/>
+          <a:p>
+            <a:pPr indent="0" marL="0">
+              <a:buNone/>
+            </a:pPr>
+            <a:r>
+              <a:rPr lang="en-US" sz="1200" b="1" spc="200" kern="0" dirty="0">
+                <a:solidFill>
+                  <a:srgbClr val="1557A6"/>
+                </a:solidFill>
+                <a:latin typeface="Arial" pitchFamily="34" charset="0"/>
+                <a:ea typeface="Arial" pitchFamily="34" charset="-122"/>
+                <a:cs typeface="Arial" pitchFamily="34" charset="-120"/>
+              </a:rPr>
+              <a:t>THE PROBLEM WE ARE TRYING TO SOLVE</a:t>
+            </a:r>
+            <a:endParaRPr lang="en-US" sz="1200" dirty="0"/>
           </a:p>
         </p:txBody>
       </p:sp>
@@ -16465,40 +16465,187 @@
         </p:nvSpPr>
         <p:spPr>
           <a:xfrm>
-            <a:off x="1984248" y="3566160"/>
-            <a:ext cx="8229600" cy="914400"/>
-          </a:xfrm>
-          <a:prstGeom prst="rect">
-            <a:avLst/>
-          </a:prstGeom>
-          <a:noFill/>
-          <a:ln/>
-        </p:spPr>
-        <p:txBody>
-          <a:bodyPr wrap="square" rtlCol="0" anchor="ctr"/>
-          <a:lstStyle/>
-          <a:p>
-            <a:pPr algn="ctr" indent="0" marL="0">
-              <a:buNone/>
-            </a:pPr>
-            <a:r>
-              <a:rPr lang="en-US" sz="1300" i="1" dirty="0">
-                <a:solidFill>
-                  <a:srgbClr val="E7D98A"/>
-                </a:solidFill>
-                <a:latin typeface="Arial" pitchFamily="34" charset="0"/>
-                <a:ea typeface="Arial" pitchFamily="34" charset="-122"/>
-                <a:cs typeface="Arial" pitchFamily="34" charset="-120"/>
-              </a:rPr>
-              <a:t>No video file exists in the repository as of this build. If a problem video has been produced outside the codebase, insert it here full-screen; otherwise narrate this transition live.</a:t>
-            </a:r>
-            <a:endParaRPr lang="en-US" sz="1300" dirty="0"/>
-          </a:p>
-        </p:txBody>
-      </p:sp>
-      <p:sp>
-        <p:nvSpPr>
-          <p:cNvPr id="4" name="Text 2"/>
+            <a:off x="548640" y="713232"/>
+            <a:ext cx="11155680" cy="914400"/>
+          </a:xfrm>
+          <a:prstGeom prst="rect">
+            <a:avLst/>
+          </a:prstGeom>
+          <a:noFill/>
+          <a:ln/>
+        </p:spPr>
+        <p:txBody>
+          <a:bodyPr wrap="square" rtlCol="0" anchor="ctr"/>
+          <a:lstStyle/>
+          <a:p>
+            <a:pPr indent="0" marL="0">
+              <a:buNone/>
+            </a:pPr>
+            <a:r>
+              <a:rPr lang="en-US" sz="2600" b="1" dirty="0">
+                <a:solidFill>
+                  <a:srgbClr val="10182F"/>
+                </a:solidFill>
+                <a:latin typeface="Arial" pitchFamily="34" charset="0"/>
+                <a:ea typeface="Arial" pitchFamily="34" charset="-122"/>
+                <a:cs typeface="Arial" pitchFamily="34" charset="-120"/>
+              </a:rPr>
+              <a:t>Five Problems iCFD Was Built to Address</a:t>
+            </a:r>
+            <a:endParaRPr lang="en-US" sz="2600" dirty="0"/>
+          </a:p>
+        </p:txBody>
+      </p:sp>
+      <p:sp>
+        <p:nvSpPr>
+          <p:cNvPr id="4" name="Shape 2"/>
+          <p:cNvSpPr/>
+          <p:nvPr/>
+        </p:nvSpPr>
+        <p:spPr>
+          <a:xfrm>
+            <a:off x="548640" y="1481328"/>
+            <a:ext cx="502920" cy="54864"/>
+          </a:xfrm>
+          <a:prstGeom prst="rect">
+            <a:avLst/>
+          </a:prstGeom>
+          <a:solidFill>
+            <a:srgbClr val="F2D21F"/>
+          </a:solidFill>
+          <a:ln/>
+        </p:spPr>
+      </p:sp>
+      <p:sp>
+        <p:nvSpPr>
+          <p:cNvPr id="5" name="Text 3"/>
+          <p:cNvSpPr/>
+          <p:nvPr/>
+        </p:nvSpPr>
+        <p:spPr>
+          <a:xfrm>
+            <a:off x="640080" y="1828800"/>
+            <a:ext cx="10881360" cy="4389120"/>
+          </a:xfrm>
+          <a:prstGeom prst="rect">
+            <a:avLst/>
+          </a:prstGeom>
+          <a:noFill/>
+          <a:ln/>
+        </p:spPr>
+        <p:txBody>
+          <a:bodyPr wrap="square" rtlCol="0" anchor="ctr"/>
+          <a:lstStyle/>
+          <a:p>
+            <a:pPr marL="342900" indent="-342900">
+              <a:spcAft>
+                <a:spcPts val="800"/>
+              </a:spcAft>
+              <a:buSzPct val="100000"/>
+              <a:buChar char="•"/>
+            </a:pPr>
+            <a:r>
+              <a:rPr lang="en-US" sz="1500" dirty="0">
+                <a:solidFill>
+                  <a:srgbClr val="1A1F2B"/>
+                </a:solidFill>
+                <a:latin typeface="Arial" pitchFamily="34" charset="0"/>
+                <a:ea typeface="Arial" pitchFamily="34" charset="-122"/>
+                <a:cs typeface="Arial" pitchFamily="34" charset="-120"/>
+              </a:rPr>
+              <a:t>Catholic teaching material is scattered across many disconnected sources — Bible, Catechism, Church documents, apologetics, theology, Church Fathers.</a:t>
+            </a:r>
+            <a:endParaRPr lang="en-US" sz="1500" dirty="0"/>
+          </a:p>
+          <a:p>
+            <a:pPr marL="342900" indent="-342900">
+              <a:spcAft>
+                <a:spcPts val="800"/>
+              </a:spcAft>
+              <a:buSzPct val="100000"/>
+              <a:buChar char="•"/>
+            </a:pPr>
+            <a:r>
+              <a:rPr lang="en-US" sz="1500" dirty="0">
+                <a:solidFill>
+                  <a:srgbClr val="1A1F2B"/>
+                </a:solidFill>
+                <a:latin typeface="Arial" pitchFamily="34" charset="0"/>
+                <a:ea typeface="Arial" pitchFamily="34" charset="-122"/>
+                <a:cs typeface="Arial" pitchFamily="34" charset="-120"/>
+              </a:rPr>
+              <a:t>Members don't know where to start or what to study next — there is no guided path through the material.</a:t>
+            </a:r>
+            <a:endParaRPr lang="en-US" sz="1500" dirty="0"/>
+          </a:p>
+          <a:p>
+            <a:pPr marL="342900" indent="-342900">
+              <a:spcAft>
+                <a:spcPts val="800"/>
+              </a:spcAft>
+              <a:buSzPct val="100000"/>
+              <a:buChar char="•"/>
+            </a:pPr>
+            <a:r>
+              <a:rPr lang="en-US" sz="1500" dirty="0">
+                <a:solidFill>
+                  <a:srgbClr val="1A1F2B"/>
+                </a:solidFill>
+                <a:latin typeface="Arial" pitchFamily="34" charset="0"/>
+                <a:ea typeface="Arial" pitchFamily="34" charset="-122"/>
+                <a:cs typeface="Arial" pitchFamily="34" charset="-120"/>
+              </a:rPr>
+              <a:t>There is no simple way to evaluate how well a member is actually learning — formation has no measurable feedback loop.</a:t>
+            </a:r>
+            <a:endParaRPr lang="en-US" sz="1500" dirty="0"/>
+          </a:p>
+          <a:p>
+            <a:pPr marL="342900" indent="-342900">
+              <a:spcAft>
+                <a:spcPts val="800"/>
+              </a:spcAft>
+              <a:buSzPct val="100000"/>
+              <a:buChar char="•"/>
+            </a:pPr>
+            <a:r>
+              <a:rPr lang="en-US" sz="1500" dirty="0">
+                <a:solidFill>
+                  <a:srgbClr val="1A1F2B"/>
+                </a:solidFill>
+                <a:latin typeface="Arial" pitchFamily="34" charset="0"/>
+                <a:ea typeface="Arial" pitchFamily="34" charset="-122"/>
+                <a:cs typeface="Arial" pitchFamily="34" charset="-120"/>
+              </a:rPr>
+              <a:t>Educators and catechists lack a focused tool to guide members with good content — most teaching still depends on scattered personal effort.</a:t>
+            </a:r>
+            <a:endParaRPr lang="en-US" sz="1500" dirty="0"/>
+          </a:p>
+          <a:p>
+            <a:pPr marL="342900" indent="-342900">
+              <a:spcAft>
+                <a:spcPts val="800"/>
+              </a:spcAft>
+              <a:buSzPct val="100000"/>
+              <a:buChar char="•"/>
+            </a:pPr>
+            <a:r>
+              <a:rPr lang="en-US" sz="1500" dirty="0">
+                <a:solidFill>
+                  <a:srgbClr val="1A1F2B"/>
+                </a:solidFill>
+                <a:latin typeface="Arial" pitchFamily="34" charset="0"/>
+                <a:ea typeface="Arial" pitchFamily="34" charset="-122"/>
+                <a:cs typeface="Arial" pitchFamily="34" charset="-120"/>
+              </a:rPr>
+              <a:t>Existing material isn't always available offline or in the member's own language (Cebuano, Tagalog).</a:t>
+            </a:r>
+            <a:endParaRPr lang="en-US" sz="1500" dirty="0"/>
+          </a:p>
+        </p:txBody>
+      </p:sp>
+      <p:sp>
+        <p:nvSpPr>
+          <p:cNvPr id="6" name="Text 4"/>
           <p:cNvSpPr/>
           <p:nvPr/>
         </p:nvSpPr>
@@ -16523,7 +16670,7 @@
             <a:r>
               <a:rPr lang="en-US" sz="1000" dirty="0">
                 <a:solidFill>
-                  <a:srgbClr val="C9D3EA"/>
+                  <a:srgbClr val="5B6472"/>
                 </a:solidFill>
                 <a:latin typeface="Arial" pitchFamily="34" charset="0"/>
                 <a:ea typeface="Arial" pitchFamily="34" charset="-122"/>
@@ -16537,7 +16684,7 @@
       </p:sp>
       <p:sp>
         <p:nvSpPr>
-          <p:cNvPr id="5" name="Text 3"/>
+          <p:cNvPr id="7" name="Text 5"/>
           <p:cNvSpPr/>
           <p:nvPr/>
         </p:nvSpPr>
@@ -16562,7 +16709,7 @@
             <a:r>
               <a:rPr lang="en-US" sz="1000" dirty="0">
                 <a:solidFill>
-                  <a:srgbClr val="C9D3EA"/>
+                  <a:srgbClr val="5B6472"/>
                 </a:solidFill>
                 <a:latin typeface="Arial" pitchFamily="34" charset="0"/>
                 <a:ea typeface="Arial" pitchFamily="34" charset="-122"/>

</xml_diff>